<commit_message>
Add package/client-SDK dependency diagram + 2 architecture slides in PPT
</commit_message>
<xml_diff>
--- a/PetStore_Architecture_LLD.pptx
+++ b/PetStore_Architecture_LLD.pptx
@@ -52,6 +52,8 @@
     <p:sldId id="300" r:id="rId51"/>
     <p:sldId id="301" r:id="rId52"/>
     <p:sldId id="302" r:id="rId53"/>
+    <p:sldId id="303" r:id="rId54"/>
+    <p:sldId id="304" r:id="rId55"/>
   </p:sldIdLst>
   <p:sldSz cx="12191695" cy="6858000" type="screen4x3"/>
   <p:notesSz cx="6858000" cy="9144000"/>
@@ -21381,7 +21383,7 @@
                         </a:defRPr>
                       </a:pPr>
                       <a:r>
-                        <a:t>New petstore-spring/; legacy read-only</a:t>
+                        <a:t>New petstore-app-v1/; legacy read-only</a:t>
                       </a:r>
                     </a:p>
                   </a:txBody>
@@ -22715,7 +22717,7 @@
                 </a:solidFill>
                 <a:latin typeface="Calibri"/>
               </a:rPr>
-              <a:t>Implementation Status — petstore-spring</a:t>
+              <a:t>Implementation Status — petstore-app-v1</a:t>
             </a:r>
           </a:p>
         </p:txBody>
@@ -27749,7 +27751,7 @@
                         </a:defRPr>
                       </a:pPr>
                       <a:r>
-                        <a:t>warehouse-service</a:t>
+                        <a:t>admin-office-service</a:t>
                       </a:r>
                     </a:p>
                   </a:txBody>
@@ -28178,6 +28180,318 @@
           </a:p>
         </p:txBody>
       </p:sp>
+    </p:spTree>
+  </p:cSld>
+  <p:clrMapOvr>
+    <a:masterClrMapping/>
+  </p:clrMapOvr>
+</p:sld>
+</file>
+
+<file path=ppt/slides/slide48.xml><?xml version="1.0" encoding="utf-8"?>
+<p:sld xmlns:a="http://schemas.openxmlformats.org/drawingml/2006/main" xmlns:p="http://schemas.openxmlformats.org/presentationml/2006/main" xmlns:r="http://schemas.openxmlformats.org/officeDocument/2006/relationships">
+  <p:cSld>
+    <p:spTree>
+      <p:nvGrpSpPr>
+        <p:cNvPr id="1" name=""/>
+        <p:cNvGrpSpPr/>
+        <p:nvPr/>
+      </p:nvGrpSpPr>
+      <p:grpSpPr/>
+      <p:sp>
+        <p:nvSpPr>
+          <p:cNvPr id="2" name="Rectangle 1"/>
+          <p:cNvSpPr/>
+          <p:nvPr/>
+        </p:nvSpPr>
+        <p:spPr>
+          <a:xfrm>
+            <a:off x="0" y="0"/>
+            <a:ext cx="12191695" cy="1051560"/>
+          </a:xfrm>
+          <a:prstGeom prst="rect">
+            <a:avLst/>
+          </a:prstGeom>
+          <a:solidFill>
+            <a:srgbClr val="1F3355"/>
+          </a:solidFill>
+          <a:ln>
+            <a:noFill/>
+          </a:ln>
+          <a:effectLst/>
+        </p:spPr>
+        <p:style>
+          <a:lnRef idx="1">
+            <a:schemeClr val="accent1"/>
+          </a:lnRef>
+          <a:fillRef idx="3">
+            <a:schemeClr val="accent1"/>
+          </a:fillRef>
+          <a:effectRef idx="2">
+            <a:schemeClr val="accent1"/>
+          </a:effectRef>
+          <a:fontRef idx="minor">
+            <a:schemeClr val="lt1"/>
+          </a:fontRef>
+        </p:style>
+        <p:txBody>
+          <a:bodyPr rtlCol="0" anchor="ctr"/>
+          <a:lstStyle/>
+          <a:p>
+            <a:pPr algn="ctr"/>
+          </a:p>
+        </p:txBody>
+      </p:sp>
+      <p:sp>
+        <p:nvSpPr>
+          <p:cNvPr id="3" name="TextBox 2"/>
+          <p:cNvSpPr txBox="1"/>
+          <p:nvPr/>
+        </p:nvSpPr>
+        <p:spPr>
+          <a:xfrm>
+            <a:off x="457200" y="109728"/>
+            <a:ext cx="11247120" cy="640080"/>
+          </a:xfrm>
+          <a:prstGeom prst="rect">
+            <a:avLst/>
+          </a:prstGeom>
+          <a:noFill/>
+        </p:spPr>
+        <p:txBody>
+          <a:bodyPr wrap="square" anchor="ctr">
+            <a:spAutoFit/>
+          </a:bodyPr>
+          <a:lstStyle/>
+          <a:p>
+            <a:pPr algn="l"/>
+            <a:r>
+              <a:rPr sz="2800" b="1">
+                <a:solidFill>
+                  <a:srgbClr val="FFFFFF"/>
+                </a:solidFill>
+                <a:latin typeface="Calibri"/>
+              </a:rPr>
+              <a:t>Migrated Architecture — As-Built (8 services + broker)</a:t>
+            </a:r>
+          </a:p>
+        </p:txBody>
+      </p:sp>
+      <p:sp>
+        <p:nvSpPr>
+          <p:cNvPr id="4" name="TextBox 3"/>
+          <p:cNvSpPr txBox="1"/>
+          <p:nvPr/>
+        </p:nvSpPr>
+        <p:spPr>
+          <a:xfrm>
+            <a:off x="457200" y="658368"/>
+            <a:ext cx="11247120" cy="320040"/>
+          </a:xfrm>
+          <a:prstGeom prst="rect">
+            <a:avLst/>
+          </a:prstGeom>
+          <a:noFill/>
+        </p:spPr>
+        <p:txBody>
+          <a:bodyPr wrap="square" anchor="t">
+            <a:spAutoFit/>
+          </a:bodyPr>
+          <a:lstStyle/>
+          <a:p>
+            <a:pPr algn="l"/>
+            <a:r>
+              <a:rPr sz="1300" b="0">
+                <a:solidFill>
+                  <a:srgbClr val="C5D3E6"/>
+                </a:solidFill>
+                <a:latin typeface="Calibri"/>
+              </a:rPr>
+              <a:t>solid = HTTP/REST · dashed red = JMS · dotted grey = library/SDK imports · run: python3 petstore_architecture.py</a:t>
+            </a:r>
+          </a:p>
+        </p:txBody>
+      </p:sp>
+      <p:pic>
+        <p:nvPicPr>
+          <p:cNvPr id="5" name="Picture 4" descr="petstore_architecture.png"/>
+          <p:cNvPicPr>
+            <a:picLocks noChangeAspect="1"/>
+          </p:cNvPicPr>
+          <p:nvPr/>
+        </p:nvPicPr>
+        <p:blipFill>
+          <a:blip r:embed="rId2"/>
+          <a:stretch>
+            <a:fillRect/>
+          </a:stretch>
+        </p:blipFill>
+        <p:spPr>
+          <a:xfrm>
+            <a:off x="1284901" y="1143000"/>
+            <a:ext cx="9621893" cy="5394960"/>
+          </a:xfrm>
+          <a:prstGeom prst="rect">
+            <a:avLst/>
+          </a:prstGeom>
+        </p:spPr>
+      </p:pic>
+    </p:spTree>
+  </p:cSld>
+  <p:clrMapOvr>
+    <a:masterClrMapping/>
+  </p:clrMapOvr>
+</p:sld>
+</file>
+
+<file path=ppt/slides/slide49.xml><?xml version="1.0" encoding="utf-8"?>
+<p:sld xmlns:a="http://schemas.openxmlformats.org/drawingml/2006/main" xmlns:p="http://schemas.openxmlformats.org/presentationml/2006/main" xmlns:r="http://schemas.openxmlformats.org/officeDocument/2006/relationships">
+  <p:cSld>
+    <p:spTree>
+      <p:nvGrpSpPr>
+        <p:cNvPr id="1" name=""/>
+        <p:cNvGrpSpPr/>
+        <p:nvPr/>
+      </p:nvGrpSpPr>
+      <p:grpSpPr/>
+      <p:sp>
+        <p:nvSpPr>
+          <p:cNvPr id="2" name="Rectangle 1"/>
+          <p:cNvSpPr/>
+          <p:nvPr/>
+        </p:nvSpPr>
+        <p:spPr>
+          <a:xfrm>
+            <a:off x="0" y="0"/>
+            <a:ext cx="12191695" cy="1051560"/>
+          </a:xfrm>
+          <a:prstGeom prst="rect">
+            <a:avLst/>
+          </a:prstGeom>
+          <a:solidFill>
+            <a:srgbClr val="1F3355"/>
+          </a:solidFill>
+          <a:ln>
+            <a:noFill/>
+          </a:ln>
+          <a:effectLst/>
+        </p:spPr>
+        <p:style>
+          <a:lnRef idx="1">
+            <a:schemeClr val="accent1"/>
+          </a:lnRef>
+          <a:fillRef idx="3">
+            <a:schemeClr val="accent1"/>
+          </a:fillRef>
+          <a:effectRef idx="2">
+            <a:schemeClr val="accent1"/>
+          </a:effectRef>
+          <a:fontRef idx="minor">
+            <a:schemeClr val="lt1"/>
+          </a:fontRef>
+        </p:style>
+        <p:txBody>
+          <a:bodyPr rtlCol="0" anchor="ctr"/>
+          <a:lstStyle/>
+          <a:p>
+            <a:pPr algn="ctr"/>
+          </a:p>
+        </p:txBody>
+      </p:sp>
+      <p:sp>
+        <p:nvSpPr>
+          <p:cNvPr id="3" name="TextBox 2"/>
+          <p:cNvSpPr txBox="1"/>
+          <p:nvPr/>
+        </p:nvSpPr>
+        <p:spPr>
+          <a:xfrm>
+            <a:off x="457200" y="109728"/>
+            <a:ext cx="11247120" cy="640080"/>
+          </a:xfrm>
+          <a:prstGeom prst="rect">
+            <a:avLst/>
+          </a:prstGeom>
+          <a:noFill/>
+        </p:spPr>
+        <p:txBody>
+          <a:bodyPr wrap="square" anchor="ctr">
+            <a:spAutoFit/>
+          </a:bodyPr>
+          <a:lstStyle/>
+          <a:p>
+            <a:pPr algn="l"/>
+            <a:r>
+              <a:rPr sz="2800" b="1">
+                <a:solidFill>
+                  <a:srgbClr val="FFFFFF"/>
+                </a:solidFill>
+                <a:latin typeface="Calibri"/>
+              </a:rPr>
+              <a:t>Package &amp; Client-SDK Dependencies (Maven)</a:t>
+            </a:r>
+          </a:p>
+        </p:txBody>
+      </p:sp>
+      <p:sp>
+        <p:nvSpPr>
+          <p:cNvPr id="4" name="TextBox 3"/>
+          <p:cNvSpPr txBox="1"/>
+          <p:nvPr/>
+        </p:nvSpPr>
+        <p:spPr>
+          <a:xfrm>
+            <a:off x="457200" y="658368"/>
+            <a:ext cx="11247120" cy="320040"/>
+          </a:xfrm>
+          <a:prstGeom prst="rect">
+            <a:avLst/>
+          </a:prstGeom>
+          <a:noFill/>
+        </p:spPr>
+        <p:txBody>
+          <a:bodyPr wrap="square" anchor="t">
+            <a:spAutoFit/>
+          </a:bodyPr>
+          <a:lstStyle/>
+          <a:p>
+            <a:pPr algn="l"/>
+            <a:r>
+              <a:rPr sz="1300" b="0">
+                <a:solidFill>
+                  <a:srgbClr val="C5D3E6"/>
+                </a:solidFill>
+                <a:latin typeface="Calibri"/>
+              </a:rPr>
+              <a:t>green = service publishes its SDK · blue = imports a client SDK (HTTP) · grey = imports a shared library (in-process)</a:t>
+            </a:r>
+          </a:p>
+        </p:txBody>
+      </p:sp>
+      <p:pic>
+        <p:nvPicPr>
+          <p:cNvPr id="5" name="Picture 4" descr="petstore_packages.png"/>
+          <p:cNvPicPr>
+            <a:picLocks noChangeAspect="1"/>
+          </p:cNvPicPr>
+          <p:nvPr/>
+        </p:nvPicPr>
+        <p:blipFill>
+          <a:blip r:embed="rId2"/>
+          <a:stretch>
+            <a:fillRect/>
+          </a:stretch>
+        </p:blipFill>
+        <p:spPr>
+          <a:xfrm>
+            <a:off x="2388966" y="1143000"/>
+            <a:ext cx="7413763" cy="5394960"/>
+          </a:xfrm>
+          <a:prstGeom prst="rect">
+            <a:avLst/>
+          </a:prstGeom>
+        </p:spPr>
+      </p:pic>
     </p:spTree>
   </p:cSld>
   <p:clrMapOvr>

</xml_diff>